<commit_message>
Update Kokao Doctors one-pager assets and metadata
Replit-Commit-Author: Agent
</commit_message>
<xml_diff>
--- a/assets/kokao-doctors-onepager.pptx
+++ b/assets/kokao-doctors-onepager.pptx
@@ -877,79 +877,65 @@
       </p:grpSpPr>
       <p:sp>
         <p:nvSpPr>
-          <p:cNvPr id="2" name="Shape 0"/>
-          <p:cNvSpPr/>
-          <p:nvPr/>
-        </p:nvSpPr>
-        <p:spPr>
-          <a:xfrm>
-            <a:off x="502920" y="411480"/>
-            <a:ext cx="310896" cy="310896"/>
+          <p:cNvPr id="2" name="Text 0"/>
+          <p:cNvSpPr/>
+          <p:nvPr/>
+        </p:nvSpPr>
+        <p:spPr>
+          <a:xfrm>
+            <a:off x="502920" y="292608"/>
+            <a:ext cx="1463040" cy="548640"/>
+          </a:xfrm>
+          <a:prstGeom prst="rect">
+            <a:avLst/>
+          </a:prstGeom>
+          <a:noFill/>
+          <a:ln/>
+        </p:spPr>
+        <p:txBody>
+          <a:bodyPr wrap="square" rtlCol="0" anchor="ctr"/>
+          <a:lstStyle/>
+          <a:p>
+            <a:pPr indent="0" marL="0">
+              <a:buNone/>
+            </a:pPr>
+            <a:r>
+              <a:rPr lang="en-US" sz="2600" b="1" spc="-100" kern="0" dirty="0">
+                <a:solidFill>
+                  <a:srgbClr val="14141A"/>
+                </a:solidFill>
+                <a:latin typeface="Arial" pitchFamily="34" charset="0"/>
+                <a:ea typeface="Arial" pitchFamily="34" charset="-122"/>
+                <a:cs typeface="Arial" pitchFamily="34" charset="-120"/>
+              </a:rPr>
+              <a:t>KOKA</a:t>
+            </a:r>
+            <a:endParaRPr lang="en-US" sz="2600" dirty="0"/>
+          </a:p>
+        </p:txBody>
+      </p:sp>
+      <p:sp>
+        <p:nvSpPr>
+          <p:cNvPr id="3" name="Shape 1"/>
+          <p:cNvSpPr/>
+          <p:nvPr/>
+        </p:nvSpPr>
+        <p:spPr>
+          <a:xfrm>
+            <a:off x="1673352" y="402336"/>
+            <a:ext cx="329184" cy="329184"/>
           </a:xfrm>
           <a:prstGeom prst="ellipse">
             <a:avLst/>
           </a:prstGeom>
           <a:noFill/>
-          <a:ln w="76200">
+          <a:ln w="88900">
             <a:solidFill>
-              <a:srgbClr val="9BF80A"/>
+              <a:srgbClr val="6D42F0"/>
             </a:solidFill>
             <a:prstDash val="solid"/>
           </a:ln>
         </p:spPr>
-      </p:sp>
-      <p:sp>
-        <p:nvSpPr>
-          <p:cNvPr id="3" name="Text 1"/>
-          <p:cNvSpPr/>
-          <p:nvPr/>
-        </p:nvSpPr>
-        <p:spPr>
-          <a:xfrm>
-            <a:off x="868680" y="292608"/>
-            <a:ext cx="2286000" cy="548640"/>
-          </a:xfrm>
-          <a:prstGeom prst="rect">
-            <a:avLst/>
-          </a:prstGeom>
-          <a:noFill/>
-          <a:ln/>
-        </p:spPr>
-        <p:txBody>
-          <a:bodyPr wrap="square" rtlCol="0" anchor="ctr"/>
-          <a:lstStyle/>
-          <a:p>
-            <a:pPr indent="0" marL="0">
-              <a:buNone/>
-            </a:pPr>
-            <a:r>
-              <a:rPr lang="en-US" sz="2600" b="1" dirty="0">
-                <a:solidFill>
-                  <a:srgbClr val="14141A"/>
-                </a:solidFill>
-                <a:latin typeface="Arial" pitchFamily="34" charset="0"/>
-                <a:ea typeface="Arial" pitchFamily="34" charset="-122"/>
-                <a:cs typeface="Arial" pitchFamily="34" charset="-120"/>
-              </a:rPr>
-              <a:t>KOKA</a:t>
-            </a:r>
-            <a:pPr indent="0" marL="0">
-              <a:buNone/>
-            </a:pPr>
-            <a:r>
-              <a:rPr lang="en-US" sz="2600" b="1" dirty="0">
-                <a:solidFill>
-                  <a:srgbClr val="9BF80A"/>
-                </a:solidFill>
-                <a:latin typeface="Arial" pitchFamily="34" charset="0"/>
-                <a:ea typeface="Arial" pitchFamily="34" charset="-122"/>
-                <a:cs typeface="Arial" pitchFamily="34" charset="-120"/>
-              </a:rPr>
-              <a:t>O</a:t>
-            </a:r>
-            <a:endParaRPr lang="en-US" sz="2600" dirty="0"/>
-          </a:p>
-        </p:txBody>
       </p:sp>
       <p:sp>
         <p:nvSpPr>
@@ -1421,7 +1407,7 @@
             <a:r>
               <a:rPr lang="en-US" sz="1100" b="1" dirty="0">
                 <a:solidFill>
-                  <a:srgbClr val="9BF80A"/>
+                  <a:srgbClr val="CBB8F5"/>
                 </a:solidFill>
               </a:rPr>
               <a:t>1</a:t>
@@ -1531,7 +1517,7 @@
             <a:r>
               <a:rPr lang="en-US" sz="1100" b="1" dirty="0">
                 <a:solidFill>
-                  <a:srgbClr val="9BF80A"/>
+                  <a:srgbClr val="CBB8F5"/>
                 </a:solidFill>
               </a:rPr>
               <a:t>2</a:t>
@@ -1641,7 +1627,7 @@
             <a:r>
               <a:rPr lang="en-US" sz="1100" b="1" dirty="0">
                 <a:solidFill>
-                  <a:srgbClr val="9BF80A"/>
+                  <a:srgbClr val="CBB8F5"/>
                 </a:solidFill>
               </a:rPr>
               <a:t>3</a:t>
@@ -1751,7 +1737,7 @@
             <a:r>
               <a:rPr lang="en-US" sz="1100" b="1" dirty="0">
                 <a:solidFill>
-                  <a:srgbClr val="9BF80A"/>
+                  <a:srgbClr val="CBB8F5"/>
                 </a:solidFill>
               </a:rPr>
               <a:t>4</a:t>
@@ -1866,7 +1852,7 @@
             <a:r>
               <a:rPr lang="en-US" sz="1800" b="1" dirty="0">
                 <a:solidFill>
-                  <a:srgbClr val="9BF80A"/>
+                  <a:srgbClr val="CBB8F5"/>
                 </a:solidFill>
               </a:rPr>
               <a:t>1/10th</a:t>
@@ -1883,7 +1869,7 @@
             <a:r>
               <a:rPr lang="en-US" sz="1800" b="1" dirty="0">
                 <a:solidFill>
-                  <a:srgbClr val="9BF80A"/>
+                  <a:srgbClr val="CBB8F5"/>
                 </a:solidFill>
               </a:rPr>
               <a:t>the cost</a:t>
@@ -2023,7 +2009,7 @@
                   <a:srgbClr val="14141A"/>
                 </a:solidFill>
                 <a:highlight>
-                  <a:srgbClr val="9BF80A"/>
+                  <a:srgbClr val="CBB8F5"/>
                 </a:highlight>
               </a:rPr>
               <a:t>app.kokao.in</a:t>

</xml_diff>